<commit_message>
fix: preserve report cover across office renderers
</commit_message>
<xml_diff>
--- a/한국철도공사_은하철도99_결과보고서.pptx
+++ b/한국철도공사_은하철도99_결과보고서.pptx
@@ -2,25 +2,25 @@
 <file path=ppt/presentation.xml><?xml version="1.0" encoding="utf-8"?>
 <p:presentation xmlns:p="http://schemas.openxmlformats.org/presentationml/2006/main">
   <p:sldMasterIdLst>
-    <p:sldMasterId xmlns:r="http://schemas.openxmlformats.org/officeDocument/2006/relationships" id="2147483648" r:id="R43094231d8194906"/>
+    <p:sldMasterId xmlns:r="http://schemas.openxmlformats.org/officeDocument/2006/relationships" id="2147483648" r:id="R45c9024f1add42ec"/>
   </p:sldMasterIdLst>
   <p:notesMasterIdLst>
-    <p:notesMasterId xmlns:r="http://schemas.openxmlformats.org/officeDocument/2006/relationships" r:id="R21965b4c4d0e4392"/>
+    <p:notesMasterId xmlns:r="http://schemas.openxmlformats.org/officeDocument/2006/relationships" r:id="R894d448135b54d01"/>
   </p:notesMasterIdLst>
   <p:sldIdLst>
-    <p:sldId xmlns:r="http://schemas.openxmlformats.org/officeDocument/2006/relationships" id="256" r:id="R900f487e0caa4123"/>
-    <p:sldId xmlns:r="http://schemas.openxmlformats.org/officeDocument/2006/relationships" id="257" r:id="R91ccecd319984e66"/>
-    <p:sldId xmlns:r="http://schemas.openxmlformats.org/officeDocument/2006/relationships" id="258" r:id="Rcd12175d7e814bfb"/>
-    <p:sldId xmlns:r="http://schemas.openxmlformats.org/officeDocument/2006/relationships" id="259" r:id="R67901d4a09fe4c7c"/>
-    <p:sldId xmlns:r="http://schemas.openxmlformats.org/officeDocument/2006/relationships" id="260" r:id="R4f632c250f5948bb"/>
-    <p:sldId xmlns:r="http://schemas.openxmlformats.org/officeDocument/2006/relationships" id="261" r:id="Rbd080bc28cc34b98"/>
-    <p:sldId xmlns:r="http://schemas.openxmlformats.org/officeDocument/2006/relationships" id="262" r:id="Rd00bd2e51cdd4469"/>
-    <p:sldId xmlns:r="http://schemas.openxmlformats.org/officeDocument/2006/relationships" id="263" r:id="R6742f3a72f5b47ae"/>
-    <p:sldId xmlns:r="http://schemas.openxmlformats.org/officeDocument/2006/relationships" id="264" r:id="R43617627fc6a402d"/>
-    <p:sldId xmlns:r="http://schemas.openxmlformats.org/officeDocument/2006/relationships" id="265" r:id="R2406f5611f85421e"/>
-    <p:sldId xmlns:r="http://schemas.openxmlformats.org/officeDocument/2006/relationships" id="266" r:id="R0237afc6b0764c90"/>
-    <p:sldId xmlns:r="http://schemas.openxmlformats.org/officeDocument/2006/relationships" id="267" r:id="R38a7f57132504e43"/>
-    <p:sldId xmlns:r="http://schemas.openxmlformats.org/officeDocument/2006/relationships" id="268" r:id="R9da4e49028414256"/>
+    <p:sldId xmlns:r="http://schemas.openxmlformats.org/officeDocument/2006/relationships" id="256" r:id="R740238b32d98499b"/>
+    <p:sldId xmlns:r="http://schemas.openxmlformats.org/officeDocument/2006/relationships" id="257" r:id="Ra3680beb37da49a3"/>
+    <p:sldId xmlns:r="http://schemas.openxmlformats.org/officeDocument/2006/relationships" id="258" r:id="R3202d335105545b5"/>
+    <p:sldId xmlns:r="http://schemas.openxmlformats.org/officeDocument/2006/relationships" id="259" r:id="R1ee62479d7384043"/>
+    <p:sldId xmlns:r="http://schemas.openxmlformats.org/officeDocument/2006/relationships" id="260" r:id="R373968f2a3024c36"/>
+    <p:sldId xmlns:r="http://schemas.openxmlformats.org/officeDocument/2006/relationships" id="261" r:id="Rfb67d91059b641ca"/>
+    <p:sldId xmlns:r="http://schemas.openxmlformats.org/officeDocument/2006/relationships" id="262" r:id="R5266c6cb44ab4d68"/>
+    <p:sldId xmlns:r="http://schemas.openxmlformats.org/officeDocument/2006/relationships" id="263" r:id="Rb6a8d1605b0b434b"/>
+    <p:sldId xmlns:r="http://schemas.openxmlformats.org/officeDocument/2006/relationships" id="264" r:id="R7733d65aecb54219"/>
+    <p:sldId xmlns:r="http://schemas.openxmlformats.org/officeDocument/2006/relationships" id="265" r:id="R26aebafef45b4889"/>
+    <p:sldId xmlns:r="http://schemas.openxmlformats.org/officeDocument/2006/relationships" id="266" r:id="Rfb9be81c0f474518"/>
+    <p:sldId xmlns:r="http://schemas.openxmlformats.org/officeDocument/2006/relationships" id="267" r:id="Raa7919e0bdc94b5d"/>
+    <p:sldId xmlns:r="http://schemas.openxmlformats.org/officeDocument/2006/relationships" id="268" r:id="Ref2b55d21f874328"/>
   </p:sldIdLst>
   <p:sldSz cx="9144000" cy="6858000"/>
   <p:notesSz cx="6858000" cy="9144000"/>
@@ -1636,8 +1636,8 @@
   </p:cSld>
   <p:clrMap bg1="lt1" tx1="dk1" bg2="lt2" tx2="dk2" accent1="accent1" accent2="accent2" accent3="accent3" accent4="accent4" accent5="accent5" accent6="accent6" hlink="hlink" folHlink="folHlink"/>
   <p:sldLayoutIdLst>
-    <p:sldLayoutId xmlns:r="http://schemas.openxmlformats.org/officeDocument/2006/relationships" id="2147483649" r:id="R9d713e426ca74236"/>
-    <p:sldLayoutId xmlns:r="http://schemas.openxmlformats.org/officeDocument/2006/relationships" id="2147483650" r:id="R3d8767028e1f478a"/>
+    <p:sldLayoutId xmlns:r="http://schemas.openxmlformats.org/officeDocument/2006/relationships" id="2147483649" r:id="Ra5f548b483da46b1"/>
+    <p:sldLayoutId xmlns:r="http://schemas.openxmlformats.org/officeDocument/2006/relationships" id="2147483650" r:id="Rae38b9f95b2b4ac3"/>
   </p:sldLayoutIdLst>
   <p:hf sldNum="0" hdr="0" ftr="0" dt="0"/>
   <p:txStyles>
@@ -2709,14 +2709,11 @@
           <p:nvPr/>
         </p:nvPicPr>
         <p:blipFill>
-          <a:blip xmlns:r="http://schemas.openxmlformats.org/officeDocument/2006/relationships" xmlns:a="http://schemas.openxmlformats.org/drawingml/2006/main" r:embed="R5d249cc19e174a0e">
-            <a:extLst>
-              <a:ext uri="{96DAC541-7B7A-43D3-8B79-37D633B846F1}">
-                <asvg:svgBlip xmlns:asvg="http://schemas.microsoft.com/office/drawing/2016/SVG/main" r:embed="Rd4ac3474ed594509"/>
-              </a:ext>
-            </a:extLst>
-          </a:blip>
-          <a:stretch xmlns:a="http://schemas.openxmlformats.org/drawingml/2006/main"/>
+          <a:blip xmlns:r="http://schemas.openxmlformats.org/officeDocument/2006/relationships" xmlns:a="http://schemas.openxmlformats.org/drawingml/2006/main" r:embed="R89738220565b4b78"/>
+          <a:srcRect xmlns:a="http://schemas.openxmlformats.org/drawingml/2006/main" l="0" t="17" r="0" b="17"/>
+          <a:stretch xmlns:a="http://schemas.openxmlformats.org/drawingml/2006/main">
+            <a:fillRect l="0" t="0" r="0" b="0"/>
+          </a:stretch>
         </p:blipFill>
         <p:spPr>
           <a:xfrm xmlns:a="http://schemas.openxmlformats.org/drawingml/2006/main">
@@ -2737,7 +2734,7 @@
           <p:nvPr/>
         </p:nvPicPr>
         <p:blipFill>
-          <a:blip xmlns:r="http://schemas.openxmlformats.org/officeDocument/2006/relationships" xmlns:a="http://schemas.openxmlformats.org/drawingml/2006/main" r:embed="Rb5f3cfaedc3e4907"/>
+          <a:blip xmlns:r="http://schemas.openxmlformats.org/officeDocument/2006/relationships" xmlns:a="http://schemas.openxmlformats.org/drawingml/2006/main" r:embed="R201e40ab90bc4dcf"/>
           <a:stretch xmlns:a="http://schemas.openxmlformats.org/drawingml/2006/main"/>
         </p:blipFill>
         <p:spPr>
@@ -7538,7 +7535,7 @@
           <p:nvPr/>
         </p:nvPicPr>
         <p:blipFill>
-          <a:blip xmlns:r="http://schemas.openxmlformats.org/officeDocument/2006/relationships" xmlns:a="http://schemas.openxmlformats.org/drawingml/2006/main" r:embed="R0b55331a77474225"/>
+          <a:blip xmlns:r="http://schemas.openxmlformats.org/officeDocument/2006/relationships" xmlns:a="http://schemas.openxmlformats.org/drawingml/2006/main" r:embed="R69a4b90de1be4ee8"/>
           <a:stretch xmlns:a="http://schemas.openxmlformats.org/drawingml/2006/main">
             <a:fillRect l="0" t="0" r="0" b="0"/>
           </a:stretch>
@@ -13053,7 +13050,7 @@
       <p:sp>
         <p:nvSpPr>
           <p:cNvPr id="54" name="Text 52">
-            <a:hlinkClick xmlns:r="http://schemas.openxmlformats.org/officeDocument/2006/relationships" xmlns:a="http://schemas.openxmlformats.org/drawingml/2006/main" r:id="Rfd4fcb5559e24fe8"/>
+            <a:hlinkClick xmlns:r="http://schemas.openxmlformats.org/officeDocument/2006/relationships" xmlns:a="http://schemas.openxmlformats.org/drawingml/2006/main" r:id="Rabbf932711a9473f"/>
             <a:extLst xmlns:a="http://schemas.openxmlformats.org/drawingml/2006/main">
               <a:ext uri="{FF2B5EF4-FFF2-40B4-BE49-F238E27FC236}">
                 <a16:creationId xmlns:a16="http://schemas.microsoft.com/office/drawing/2014/main" id="{97EBEDE3-6E48-46D6-8E30-7C19C5507B41}"/>
@@ -13092,7 +13089,7 @@
                 <a:latin typeface="NanumGothic"/>
                 <a:ea typeface="NanumGothic"/>
                 <a:cs typeface="NanumGothic"/>
-                <a:hlinkClick xmlns:r="http://schemas.openxmlformats.org/officeDocument/2006/relationships" r:id="R0d427a03a2c444aa"/>
+                <a:hlinkClick xmlns:r="http://schemas.openxmlformats.org/officeDocument/2006/relationships" r:id="R0461617ce4dd40b7"/>
               </a:rPr>
               <a:t>github.com/tory-win/Galaxy_Express_99</a:t>
             </a:r>
@@ -13151,7 +13148,7 @@
       <p:sp>
         <p:nvSpPr>
           <p:cNvPr id="56" name="Text 54">
-            <a:hlinkClick xmlns:r="http://schemas.openxmlformats.org/officeDocument/2006/relationships" xmlns:a="http://schemas.openxmlformats.org/drawingml/2006/main" r:id="R879de67f3bf943f4"/>
+            <a:hlinkClick xmlns:r="http://schemas.openxmlformats.org/officeDocument/2006/relationships" xmlns:a="http://schemas.openxmlformats.org/drawingml/2006/main" r:id="R7859d3f6bd914053"/>
             <a:extLst xmlns:a="http://schemas.openxmlformats.org/drawingml/2006/main">
               <a:ext uri="{FF2B5EF4-FFF2-40B4-BE49-F238E27FC236}">
                 <a16:creationId xmlns:a16="http://schemas.microsoft.com/office/drawing/2014/main" id="{E26D17C6-414A-48CB-91AD-3EB842BC582E}"/>
@@ -13190,7 +13187,7 @@
                 <a:latin typeface="NanumGothic"/>
                 <a:ea typeface="NanumGothic"/>
                 <a:cs typeface="NanumGothic"/>
-                <a:hlinkClick xmlns:r="http://schemas.openxmlformats.org/officeDocument/2006/relationships" r:id="R53a70714dea142db"/>
+                <a:hlinkClick xmlns:r="http://schemas.openxmlformats.org/officeDocument/2006/relationships" r:id="R554a55fad7ef4af7"/>
               </a:rPr>
               <a:t>…/preview/railpool-ai-demo.html</a:t>
             </a:r>
@@ -13494,7 +13491,7 @@
           <p:nvPr/>
         </p:nvPicPr>
         <p:blipFill>
-          <a:blip xmlns:r="http://schemas.openxmlformats.org/officeDocument/2006/relationships" xmlns:a="http://schemas.openxmlformats.org/drawingml/2006/main" r:embed="R6bb34450fd794332"/>
+          <a:blip xmlns:r="http://schemas.openxmlformats.org/officeDocument/2006/relationships" xmlns:a="http://schemas.openxmlformats.org/drawingml/2006/main" r:embed="Ree15c50387264ced"/>
           <a:stretch xmlns:a="http://schemas.openxmlformats.org/drawingml/2006/main">
             <a:fillRect l="0" t="0" r="0" b="0"/>
           </a:stretch>
@@ -13518,7 +13515,7 @@
           <p:nvPr/>
         </p:nvPicPr>
         <p:blipFill>
-          <a:blip xmlns:r="http://schemas.openxmlformats.org/officeDocument/2006/relationships" xmlns:a="http://schemas.openxmlformats.org/drawingml/2006/main" r:embed="R028e2266a46b4725"/>
+          <a:blip xmlns:r="http://schemas.openxmlformats.org/officeDocument/2006/relationships" xmlns:a="http://schemas.openxmlformats.org/drawingml/2006/main" r:embed="R1ddfe018aa3f4f02"/>
           <a:srcRect xmlns:a="http://schemas.openxmlformats.org/drawingml/2006/main" l="12480" t="0" r="12480" b="0"/>
           <a:stretch xmlns:a="http://schemas.openxmlformats.org/drawingml/2006/main">
             <a:fillRect l="0" t="0" r="0" b="0"/>
@@ -13539,7 +13536,7 @@
           <p:cNvPr id="26" name="Cover readability overlay">
             <a:extLst xmlns:a="http://schemas.openxmlformats.org/drawingml/2006/main">
               <a:ext uri="{FF2B5EF4-FFF2-40B4-BE49-F238E27FC236}">
-                <a16:creationId xmlns:a16="http://schemas.microsoft.com/office/drawing/2014/main" id="{B7DC32E4-17C3-4DA7-AAD6-6AA355CD12B8}"/>
+                <a16:creationId xmlns:a16="http://schemas.microsoft.com/office/drawing/2014/main" id="{4CE0065D-5EB8-4339-ACFA-AE42596C9359}"/>
               </a:ext>
             </a:extLst>
           </p:cNvPr>
@@ -13575,7 +13572,7 @@
           <p:cNvPr id="27" name="Cover headline">
             <a:extLst xmlns:a="http://schemas.openxmlformats.org/drawingml/2006/main">
               <a:ext uri="{FF2B5EF4-FFF2-40B4-BE49-F238E27FC236}">
-                <a16:creationId xmlns:a16="http://schemas.microsoft.com/office/drawing/2014/main" id="{97FA7654-2620-4214-B8D6-D5DF036E859C}"/>
+                <a16:creationId xmlns:a16="http://schemas.microsoft.com/office/drawing/2014/main" id="{8CBE2181-4D8D-4183-87C0-4C0DC34EEB5C}"/>
               </a:ext>
             </a:extLst>
           </p:cNvPr>
@@ -20534,7 +20531,7 @@
           <p:nvPr/>
         </p:nvPicPr>
         <p:blipFill>
-          <a:blip xmlns:r="http://schemas.openxmlformats.org/officeDocument/2006/relationships" xmlns:a="http://schemas.openxmlformats.org/drawingml/2006/main" r:embed="R47aa0b9c2faa4750"/>
+          <a:blip xmlns:r="http://schemas.openxmlformats.org/officeDocument/2006/relationships" xmlns:a="http://schemas.openxmlformats.org/drawingml/2006/main" r:embed="R21cc5a4f53fd49d5"/>
           <a:stretch xmlns:a="http://schemas.openxmlformats.org/drawingml/2006/main">
             <a:fillRect l="0" t="0" r="0" b="0"/>
           </a:stretch>
@@ -23682,7 +23679,7 @@
           <p:nvPr/>
         </p:nvPicPr>
         <p:blipFill>
-          <a:blip xmlns:r="http://schemas.openxmlformats.org/officeDocument/2006/relationships" xmlns:a="http://schemas.openxmlformats.org/drawingml/2006/main" r:embed="R8c0a0a2e42a44fc8"/>
+          <a:blip xmlns:r="http://schemas.openxmlformats.org/officeDocument/2006/relationships" xmlns:a="http://schemas.openxmlformats.org/drawingml/2006/main" r:embed="Rc6c9d0f22e544c33"/>
           <a:stretch xmlns:a="http://schemas.openxmlformats.org/drawingml/2006/main">
             <a:fillRect l="0" t="0" r="0" b="0"/>
           </a:stretch>
@@ -23959,7 +23956,7 @@
           <p:nvPr/>
         </p:nvPicPr>
         <p:blipFill>
-          <a:blip xmlns:r="http://schemas.openxmlformats.org/officeDocument/2006/relationships" xmlns:a="http://schemas.openxmlformats.org/drawingml/2006/main" r:embed="R5a50fb617a5b4893"/>
+          <a:blip xmlns:r="http://schemas.openxmlformats.org/officeDocument/2006/relationships" xmlns:a="http://schemas.openxmlformats.org/drawingml/2006/main" r:embed="R1c2d29df41ef4b2d"/>
           <a:stretch xmlns:a="http://schemas.openxmlformats.org/drawingml/2006/main">
             <a:fillRect l="0" t="0" r="0" b="0"/>
           </a:stretch>
@@ -24236,7 +24233,7 @@
           <p:nvPr/>
         </p:nvPicPr>
         <p:blipFill>
-          <a:blip xmlns:r="http://schemas.openxmlformats.org/officeDocument/2006/relationships" xmlns:a="http://schemas.openxmlformats.org/drawingml/2006/main" r:embed="R917de5145c79442c"/>
+          <a:blip xmlns:r="http://schemas.openxmlformats.org/officeDocument/2006/relationships" xmlns:a="http://schemas.openxmlformats.org/drawingml/2006/main" r:embed="Re447760404cc45fc"/>
           <a:stretch xmlns:a="http://schemas.openxmlformats.org/drawingml/2006/main">
             <a:fillRect l="0" t="0" r="0" b="0"/>
           </a:stretch>
@@ -24513,7 +24510,7 @@
           <p:nvPr/>
         </p:nvPicPr>
         <p:blipFill>
-          <a:blip xmlns:r="http://schemas.openxmlformats.org/officeDocument/2006/relationships" xmlns:a="http://schemas.openxmlformats.org/drawingml/2006/main" r:embed="Rece16afdb30146d3"/>
+          <a:blip xmlns:r="http://schemas.openxmlformats.org/officeDocument/2006/relationships" xmlns:a="http://schemas.openxmlformats.org/drawingml/2006/main" r:embed="R859ecf513c2e4d7c"/>
           <a:stretch xmlns:a="http://schemas.openxmlformats.org/drawingml/2006/main">
             <a:fillRect l="0" t="0" r="0" b="0"/>
           </a:stretch>
@@ -25200,7 +25197,7 @@
           <p:nvPr/>
         </p:nvPicPr>
         <p:blipFill>
-          <a:blip xmlns:r="http://schemas.openxmlformats.org/officeDocument/2006/relationships" xmlns:a="http://schemas.openxmlformats.org/drawingml/2006/main" r:embed="R5f6d21b159264e6f"/>
+          <a:blip xmlns:r="http://schemas.openxmlformats.org/officeDocument/2006/relationships" xmlns:a="http://schemas.openxmlformats.org/drawingml/2006/main" r:embed="Ra008eda65b0c4499"/>
           <a:stretch xmlns:a="http://schemas.openxmlformats.org/drawingml/2006/main">
             <a:fillRect l="0" t="0" r="0" b="0"/>
           </a:stretch>
@@ -25477,7 +25474,7 @@
           <p:nvPr/>
         </p:nvPicPr>
         <p:blipFill>
-          <a:blip xmlns:r="http://schemas.openxmlformats.org/officeDocument/2006/relationships" xmlns:a="http://schemas.openxmlformats.org/drawingml/2006/main" r:embed="Rc8a8b26cbde54506"/>
+          <a:blip xmlns:r="http://schemas.openxmlformats.org/officeDocument/2006/relationships" xmlns:a="http://schemas.openxmlformats.org/drawingml/2006/main" r:embed="R5df2a5c5f23d4b23"/>
           <a:stretch xmlns:a="http://schemas.openxmlformats.org/drawingml/2006/main">
             <a:fillRect l="0" t="0" r="0" b="0"/>
           </a:stretch>
@@ -25754,7 +25751,7 @@
           <p:nvPr/>
         </p:nvPicPr>
         <p:blipFill>
-          <a:blip xmlns:r="http://schemas.openxmlformats.org/officeDocument/2006/relationships" xmlns:a="http://schemas.openxmlformats.org/drawingml/2006/main" r:embed="R4dcaec2dc8814a9d"/>
+          <a:blip xmlns:r="http://schemas.openxmlformats.org/officeDocument/2006/relationships" xmlns:a="http://schemas.openxmlformats.org/drawingml/2006/main" r:embed="Raaae5253cea54625"/>
           <a:stretch xmlns:a="http://schemas.openxmlformats.org/drawingml/2006/main">
             <a:fillRect l="0" t="0" r="0" b="0"/>
           </a:stretch>

</xml_diff>

<commit_message>
docs: sync report with refreshed showcase video
</commit_message>
<xml_diff>
--- a/한국철도공사_은하철도99_결과보고서.pptx
+++ b/한국철도공사_은하철도99_결과보고서.pptx
@@ -2,25 +2,25 @@
 <file path=ppt/presentation.xml><?xml version="1.0" encoding="utf-8"?>
 <p:presentation xmlns:p="http://schemas.openxmlformats.org/presentationml/2006/main">
   <p:sldMasterIdLst>
-    <p:sldMasterId xmlns:r="http://schemas.openxmlformats.org/officeDocument/2006/relationships" id="2147483648" r:id="R45c9024f1add42ec"/>
+    <p:sldMasterId xmlns:r="http://schemas.openxmlformats.org/officeDocument/2006/relationships" id="2147483648" r:id="R474dc4e00f9e4a1f"/>
   </p:sldMasterIdLst>
   <p:notesMasterIdLst>
-    <p:notesMasterId xmlns:r="http://schemas.openxmlformats.org/officeDocument/2006/relationships" r:id="R894d448135b54d01"/>
+    <p:notesMasterId xmlns:r="http://schemas.openxmlformats.org/officeDocument/2006/relationships" r:id="Rbd9486fad57545d5"/>
   </p:notesMasterIdLst>
   <p:sldIdLst>
-    <p:sldId xmlns:r="http://schemas.openxmlformats.org/officeDocument/2006/relationships" id="256" r:id="R740238b32d98499b"/>
-    <p:sldId xmlns:r="http://schemas.openxmlformats.org/officeDocument/2006/relationships" id="257" r:id="Ra3680beb37da49a3"/>
-    <p:sldId xmlns:r="http://schemas.openxmlformats.org/officeDocument/2006/relationships" id="258" r:id="R3202d335105545b5"/>
-    <p:sldId xmlns:r="http://schemas.openxmlformats.org/officeDocument/2006/relationships" id="259" r:id="R1ee62479d7384043"/>
-    <p:sldId xmlns:r="http://schemas.openxmlformats.org/officeDocument/2006/relationships" id="260" r:id="R373968f2a3024c36"/>
-    <p:sldId xmlns:r="http://schemas.openxmlformats.org/officeDocument/2006/relationships" id="261" r:id="Rfb67d91059b641ca"/>
-    <p:sldId xmlns:r="http://schemas.openxmlformats.org/officeDocument/2006/relationships" id="262" r:id="R5266c6cb44ab4d68"/>
-    <p:sldId xmlns:r="http://schemas.openxmlformats.org/officeDocument/2006/relationships" id="263" r:id="Rb6a8d1605b0b434b"/>
-    <p:sldId xmlns:r="http://schemas.openxmlformats.org/officeDocument/2006/relationships" id="264" r:id="R7733d65aecb54219"/>
-    <p:sldId xmlns:r="http://schemas.openxmlformats.org/officeDocument/2006/relationships" id="265" r:id="R26aebafef45b4889"/>
-    <p:sldId xmlns:r="http://schemas.openxmlformats.org/officeDocument/2006/relationships" id="266" r:id="Rfb9be81c0f474518"/>
-    <p:sldId xmlns:r="http://schemas.openxmlformats.org/officeDocument/2006/relationships" id="267" r:id="Raa7919e0bdc94b5d"/>
-    <p:sldId xmlns:r="http://schemas.openxmlformats.org/officeDocument/2006/relationships" id="268" r:id="Ref2b55d21f874328"/>
+    <p:sldId xmlns:r="http://schemas.openxmlformats.org/officeDocument/2006/relationships" id="256" r:id="Rf942219875d44402"/>
+    <p:sldId xmlns:r="http://schemas.openxmlformats.org/officeDocument/2006/relationships" id="257" r:id="Rccd72f81ada540aa"/>
+    <p:sldId xmlns:r="http://schemas.openxmlformats.org/officeDocument/2006/relationships" id="258" r:id="Rd01483c826b34c96"/>
+    <p:sldId xmlns:r="http://schemas.openxmlformats.org/officeDocument/2006/relationships" id="259" r:id="Racd48198f16b431b"/>
+    <p:sldId xmlns:r="http://schemas.openxmlformats.org/officeDocument/2006/relationships" id="260" r:id="Rc0293baab9744268"/>
+    <p:sldId xmlns:r="http://schemas.openxmlformats.org/officeDocument/2006/relationships" id="261" r:id="R900515b6d73d4afc"/>
+    <p:sldId xmlns:r="http://schemas.openxmlformats.org/officeDocument/2006/relationships" id="262" r:id="Rd4fd2df6147a456f"/>
+    <p:sldId xmlns:r="http://schemas.openxmlformats.org/officeDocument/2006/relationships" id="263" r:id="R29662e602c1b46d0"/>
+    <p:sldId xmlns:r="http://schemas.openxmlformats.org/officeDocument/2006/relationships" id="264" r:id="R6bcb3dc415d94335"/>
+    <p:sldId xmlns:r="http://schemas.openxmlformats.org/officeDocument/2006/relationships" id="265" r:id="R9ed2667bb1b742cd"/>
+    <p:sldId xmlns:r="http://schemas.openxmlformats.org/officeDocument/2006/relationships" id="266" r:id="Rf9afb6172b684fdb"/>
+    <p:sldId xmlns:r="http://schemas.openxmlformats.org/officeDocument/2006/relationships" id="267" r:id="R6ffcc794200b4e85"/>
+    <p:sldId xmlns:r="http://schemas.openxmlformats.org/officeDocument/2006/relationships" id="268" r:id="R4d425aca58984b5e"/>
   </p:sldIdLst>
   <p:sldSz cx="9144000" cy="6858000"/>
   <p:notesSz cx="6858000" cy="9144000"/>
@@ -696,7 +696,7 @@
           </a:p>
           <a:p xmlns:a="http://schemas.openxmlformats.org/drawingml/2006/main">
             <a:r>
-              <a:t>- Narrated two-minute 1080p demo published at commit 9e8ce48; public playback, byte-range response, matching local/public hash, and mock cleanup verified.</a:t>
+              <a:t>- Refreshed two-minute 1080p demo published at commit 3295413; nine stage cards, Korean audio, console error count 0, HTTP Range 206, and matching local/public SHA-256 b02b86a7b8e62d8679c663b9e68826499076047aec0d816ecfe84c62532a9c70 verified.</a:t>
             </a:r>
             <a:endParaRPr/>
           </a:p>
@@ -862,7 +862,7 @@
           </a:p>
           <a:p xmlns:a="http://schemas.openxmlformats.org/drawingml/2006/main">
             <a:r>
-              <a:t>- Narrated two-minute demo: https://macmini.tailbba978.ts.net/galaxy-express/preview/railpool-ai-demo.html, commit 9e8ce48.</a:t>
+              <a:t>- Refreshed two-minute, nine-stage demo: https://macmini.tailbba978.ts.net/galaxy-express/preview/railpool-ai-demo.html, commit 3295413.</a:t>
             </a:r>
             <a:endParaRPr/>
           </a:p>
@@ -1636,8 +1636,8 @@
   </p:cSld>
   <p:clrMap bg1="lt1" tx1="dk1" bg2="lt2" tx2="dk2" accent1="accent1" accent2="accent2" accent3="accent3" accent4="accent4" accent5="accent5" accent6="accent6" hlink="hlink" folHlink="folHlink"/>
   <p:sldLayoutIdLst>
-    <p:sldLayoutId xmlns:r="http://schemas.openxmlformats.org/officeDocument/2006/relationships" id="2147483649" r:id="Ra5f548b483da46b1"/>
-    <p:sldLayoutId xmlns:r="http://schemas.openxmlformats.org/officeDocument/2006/relationships" id="2147483650" r:id="Rae38b9f95b2b4ac3"/>
+    <p:sldLayoutId xmlns:r="http://schemas.openxmlformats.org/officeDocument/2006/relationships" id="2147483649" r:id="R1c2b7384bf0c4f47"/>
+    <p:sldLayoutId xmlns:r="http://schemas.openxmlformats.org/officeDocument/2006/relationships" id="2147483650" r:id="R9d5962a04f0d423a"/>
   </p:sldLayoutIdLst>
   <p:hf sldNum="0" hdr="0" ftr="0" dt="0"/>
   <p:txStyles>
@@ -2709,7 +2709,7 @@
           <p:nvPr/>
         </p:nvPicPr>
         <p:blipFill>
-          <a:blip xmlns:r="http://schemas.openxmlformats.org/officeDocument/2006/relationships" xmlns:a="http://schemas.openxmlformats.org/drawingml/2006/main" r:embed="R89738220565b4b78"/>
+          <a:blip xmlns:r="http://schemas.openxmlformats.org/officeDocument/2006/relationships" xmlns:a="http://schemas.openxmlformats.org/drawingml/2006/main" r:embed="Rc0e62843caa8494e"/>
           <a:srcRect xmlns:a="http://schemas.openxmlformats.org/drawingml/2006/main" l="0" t="17" r="0" b="17"/>
           <a:stretch xmlns:a="http://schemas.openxmlformats.org/drawingml/2006/main">
             <a:fillRect l="0" t="0" r="0" b="0"/>
@@ -2734,7 +2734,7 @@
           <p:nvPr/>
         </p:nvPicPr>
         <p:blipFill>
-          <a:blip xmlns:r="http://schemas.openxmlformats.org/officeDocument/2006/relationships" xmlns:a="http://schemas.openxmlformats.org/drawingml/2006/main" r:embed="R201e40ab90bc4dcf"/>
+          <a:blip xmlns:r="http://schemas.openxmlformats.org/officeDocument/2006/relationships" xmlns:a="http://schemas.openxmlformats.org/drawingml/2006/main" r:embed="R4504ddcd767a4b9a"/>
           <a:stretch xmlns:a="http://schemas.openxmlformats.org/drawingml/2006/main"/>
         </p:blipFill>
         <p:spPr>
@@ -5457,7 +5457,7 @@
                 <a:ea typeface="NanumGothic"/>
                 <a:cs typeface="NanumGothic"/>
               </a:rPr>
-              <a:t>최신 제품 UI 80e099d와 공개 영상 9e8ce48 기준으로 빌드·테스트·Docker·390/320px 화면·공개 재생을 확인했습니다.</a:t>
+              <a:t>제품 UI 80e099d·공개 영상 3295413 기준으로 빌드·테스트·Docker·390/320px·공개 재생을 확인했습니다.</a:t>
             </a:r>
             <a:endParaRPr sz="950"/>
           </a:p>
@@ -7296,7 +7296,7 @@
         </p:spPr>
         <p:txBody>
           <a:bodyPr xmlns:a="http://schemas.openxmlformats.org/drawingml/2006/main" wrap="square" lIns="0" tIns="0" rIns="0" bIns="0" anchor="ctr">
-            <a:normAutofit fontScale="98047"/>
+            <a:normAutofit fontScale="100000"/>
           </a:bodyPr>
           <a:lstStyle xmlns:a="http://schemas.openxmlformats.org/drawingml/2006/main"/>
           <a:p xmlns:a="http://schemas.openxmlformats.org/drawingml/2006/main">
@@ -7312,7 +7312,7 @@
                 <a:ea typeface="NanumGothic"/>
                 <a:cs typeface="NanumGothic"/>
               </a:rPr>
-              <a:t>공개 2분 영상 120초 · 1080p · Range 206 · 로컬/공개 SHA-256 일치</a:t>
+              <a:t>120초·1080p·9단계 · 음성·Range 206·콘솔 오류 0·SHA-256 일치</a:t>
             </a:r>
             <a:endParaRPr sz="820"/>
           </a:p>
@@ -7535,7 +7535,7 @@
           <p:nvPr/>
         </p:nvPicPr>
         <p:blipFill>
-          <a:blip xmlns:r="http://schemas.openxmlformats.org/officeDocument/2006/relationships" xmlns:a="http://schemas.openxmlformats.org/drawingml/2006/main" r:embed="R69a4b90de1be4ee8"/>
+          <a:blip xmlns:r="http://schemas.openxmlformats.org/officeDocument/2006/relationships" xmlns:a="http://schemas.openxmlformats.org/drawingml/2006/main" r:embed="Rd70e4c7c4d634527"/>
           <a:stretch xmlns:a="http://schemas.openxmlformats.org/drawingml/2006/main">
             <a:fillRect l="0" t="0" r="0" b="0"/>
           </a:stretch>
@@ -10962,7 +10962,7 @@
                 <a:ea typeface="NanumGothic"/>
                 <a:cs typeface="NanumGothic"/>
               </a:rPr>
-              <a:t>철도 경험이 없는 물류 담당자가 2분 안에 요청부터 AI 역제안, 공동수송, 담당자 검토까지 확인하는 시나리오입니다.</a:t>
+              <a:t>코레일 앱 진입부터 음성 요청, AI 역제안, 공동수송, 담당자 검토까지 2분·9단계로 확인합니다.</a:t>
             </a:r>
             <a:endParaRPr sz="950"/>
           </a:p>
@@ -11041,7 +11041,7 @@
                 <a:ea typeface="NanumGothic"/>
                 <a:cs typeface="NanumGothic"/>
               </a:rPr>
-              <a:t>2분 사용자 시나리오</a:t>
+              <a:t>2분 핵심 사용자 시나리오</a:t>
             </a:r>
             <a:endParaRPr sz="1250"/>
           </a:p>
@@ -11249,7 +11249,7 @@
                 <a:ea typeface="NanumGothic"/>
                 <a:cs typeface="NanumGothic"/>
               </a:rPr>
-              <a:t>문제·AI 진입</a:t>
+              <a:t>18TEU·단가 훅</a:t>
             </a:r>
             <a:endParaRPr sz="780"/>
           </a:p>
@@ -11378,7 +11378,7 @@
                 <a:ea typeface="NanumGothic"/>
                 <a:cs typeface="NanumGothic"/>
               </a:rPr>
-              <a:t>0:18</a:t>
+              <a:t>0:10</a:t>
             </a:r>
             <a:endParaRPr sz="850"/>
           </a:p>
@@ -11426,7 +11426,7 @@
                 <a:ea typeface="NanumGothic"/>
                 <a:cs typeface="NanumGothic"/>
               </a:rPr>
-              <a:t>조건·검토 범위</a:t>
+              <a:t>코레일 앱 진입</a:t>
             </a:r>
             <a:endParaRPr sz="780"/>
           </a:p>
@@ -11555,7 +11555,7 @@
                 <a:ea typeface="NanumGothic"/>
                 <a:cs typeface="NanumGothic"/>
               </a:rPr>
-              <a:t>0:35</a:t>
+              <a:t>0:22</a:t>
             </a:r>
             <a:endParaRPr sz="850"/>
           </a:p>
@@ -11603,7 +11603,7 @@
                 <a:ea typeface="NanumGothic"/>
                 <a:cs typeface="NanumGothic"/>
               </a:rPr>
-              <a:t>AI 역제안</a:t>
+              <a:t>음성 요청·확인</a:t>
             </a:r>
             <a:endParaRPr sz="780"/>
           </a:p>
@@ -11732,7 +11732,7 @@
                 <a:ea typeface="NanumGothic"/>
                 <a:cs typeface="NanumGothic"/>
               </a:rPr>
-              <a:t>0:52</a:t>
+              <a:t>0:34</a:t>
             </a:r>
             <a:endParaRPr sz="850"/>
           </a:p>
@@ -11780,7 +11780,7 @@
                 <a:ea typeface="NanumGothic"/>
                 <a:cs typeface="NanumGothic"/>
               </a:rPr>
-              <a:t>D2D 근거 비교</a:t>
+              <a:t>조정 범위 선택</a:t>
             </a:r>
             <a:endParaRPr sz="780"/>
           </a:p>
@@ -11909,7 +11909,7 @@
                 <a:ea typeface="NanumGothic"/>
                 <a:cs typeface="NanumGothic"/>
               </a:rPr>
-              <a:t>1:08</a:t>
+              <a:t>0:44</a:t>
             </a:r>
             <a:endParaRPr sz="850"/>
           </a:p>
@@ -11957,7 +11957,7 @@
                 <a:ea typeface="NanumGothic"/>
                 <a:cs typeface="NanumGothic"/>
               </a:rPr>
-              <a:t>18TEU·단가</a:t>
+              <a:t>D2D 대안 비교</a:t>
             </a:r>
             <a:endParaRPr sz="780"/>
           </a:p>
@@ -12086,7 +12086,7 @@
                 <a:ea typeface="NanumGothic"/>
                 <a:cs typeface="NanumGothic"/>
               </a:rPr>
-              <a:t>1:25</a:t>
+              <a:t>1:08</a:t>
             </a:r>
             <a:endParaRPr sz="850"/>
           </a:p>
@@ -12134,7 +12134,7 @@
                 <a:ea typeface="NanumGothic"/>
                 <a:cs typeface="NanumGothic"/>
               </a:rPr>
-              <a:t>이탈·실시간 알림</a:t>
+              <a:t>공동수송·알림</a:t>
             </a:r>
             <a:endParaRPr sz="780"/>
           </a:p>
@@ -12263,7 +12263,7 @@
                 <a:ea typeface="NanumGothic"/>
                 <a:cs typeface="NanumGothic"/>
               </a:rPr>
-              <a:t>1:42</a:t>
+              <a:t>1:40</a:t>
             </a:r>
             <a:endParaRPr sz="850"/>
           </a:p>
@@ -12311,7 +12311,7 @@
                 <a:ea typeface="NanumGothic"/>
                 <a:cs typeface="NanumGothic"/>
               </a:rPr>
-              <a:t>검토 요청·사유</a:t>
+              <a:t>검토 요청·안전</a:t>
             </a:r>
             <a:endParaRPr sz="780"/>
           </a:p>
@@ -13050,7 +13050,7 @@
       <p:sp>
         <p:nvSpPr>
           <p:cNvPr id="54" name="Text 52">
-            <a:hlinkClick xmlns:r="http://schemas.openxmlformats.org/officeDocument/2006/relationships" xmlns:a="http://schemas.openxmlformats.org/drawingml/2006/main" r:id="Rabbf932711a9473f"/>
+            <a:hlinkClick xmlns:r="http://schemas.openxmlformats.org/officeDocument/2006/relationships" xmlns:a="http://schemas.openxmlformats.org/drawingml/2006/main" r:id="R6ff89b5c568345e4"/>
             <a:extLst xmlns:a="http://schemas.openxmlformats.org/drawingml/2006/main">
               <a:ext uri="{FF2B5EF4-FFF2-40B4-BE49-F238E27FC236}">
                 <a16:creationId xmlns:a16="http://schemas.microsoft.com/office/drawing/2014/main" id="{97EBEDE3-6E48-46D6-8E30-7C19C5507B41}"/>
@@ -13089,7 +13089,7 @@
                 <a:latin typeface="NanumGothic"/>
                 <a:ea typeface="NanumGothic"/>
                 <a:cs typeface="NanumGothic"/>
-                <a:hlinkClick xmlns:r="http://schemas.openxmlformats.org/officeDocument/2006/relationships" r:id="R0461617ce4dd40b7"/>
+                <a:hlinkClick xmlns:r="http://schemas.openxmlformats.org/officeDocument/2006/relationships" r:id="R11a8515167444e3b"/>
               </a:rPr>
               <a:t>github.com/tory-win/Galaxy_Express_99</a:t>
             </a:r>
@@ -13148,7 +13148,7 @@
       <p:sp>
         <p:nvSpPr>
           <p:cNvPr id="56" name="Text 54">
-            <a:hlinkClick xmlns:r="http://schemas.openxmlformats.org/officeDocument/2006/relationships" xmlns:a="http://schemas.openxmlformats.org/drawingml/2006/main" r:id="R7859d3f6bd914053"/>
+            <a:hlinkClick xmlns:r="http://schemas.openxmlformats.org/officeDocument/2006/relationships" xmlns:a="http://schemas.openxmlformats.org/drawingml/2006/main" r:id="Ra74bb0d949fd4511"/>
             <a:extLst xmlns:a="http://schemas.openxmlformats.org/drawingml/2006/main">
               <a:ext uri="{FF2B5EF4-FFF2-40B4-BE49-F238E27FC236}">
                 <a16:creationId xmlns:a16="http://schemas.microsoft.com/office/drawing/2014/main" id="{E26D17C6-414A-48CB-91AD-3EB842BC582E}"/>
@@ -13187,7 +13187,7 @@
                 <a:latin typeface="NanumGothic"/>
                 <a:ea typeface="NanumGothic"/>
                 <a:cs typeface="NanumGothic"/>
-                <a:hlinkClick xmlns:r="http://schemas.openxmlformats.org/officeDocument/2006/relationships" r:id="R554a55fad7ef4af7"/>
+                <a:hlinkClick xmlns:r="http://schemas.openxmlformats.org/officeDocument/2006/relationships" r:id="Rb1bc4ad2f25344bc"/>
               </a:rPr>
               <a:t>…/preview/railpool-ai-demo.html</a:t>
             </a:r>
@@ -13491,7 +13491,7 @@
           <p:nvPr/>
         </p:nvPicPr>
         <p:blipFill>
-          <a:blip xmlns:r="http://schemas.openxmlformats.org/officeDocument/2006/relationships" xmlns:a="http://schemas.openxmlformats.org/drawingml/2006/main" r:embed="Ree15c50387264ced"/>
+          <a:blip xmlns:r="http://schemas.openxmlformats.org/officeDocument/2006/relationships" xmlns:a="http://schemas.openxmlformats.org/drawingml/2006/main" r:embed="R361bc6d4878e4ac0"/>
           <a:stretch xmlns:a="http://schemas.openxmlformats.org/drawingml/2006/main">
             <a:fillRect l="0" t="0" r="0" b="0"/>
           </a:stretch>
@@ -13515,7 +13515,7 @@
           <p:nvPr/>
         </p:nvPicPr>
         <p:blipFill>
-          <a:blip xmlns:r="http://schemas.openxmlformats.org/officeDocument/2006/relationships" xmlns:a="http://schemas.openxmlformats.org/drawingml/2006/main" r:embed="R1ddfe018aa3f4f02"/>
+          <a:blip xmlns:r="http://schemas.openxmlformats.org/officeDocument/2006/relationships" xmlns:a="http://schemas.openxmlformats.org/drawingml/2006/main" r:embed="R47b941cdb88d41eb"/>
           <a:srcRect xmlns:a="http://schemas.openxmlformats.org/drawingml/2006/main" l="12480" t="0" r="12480" b="0"/>
           <a:stretch xmlns:a="http://schemas.openxmlformats.org/drawingml/2006/main">
             <a:fillRect l="0" t="0" r="0" b="0"/>
@@ -13536,7 +13536,7 @@
           <p:cNvPr id="26" name="Cover readability overlay">
             <a:extLst xmlns:a="http://schemas.openxmlformats.org/drawingml/2006/main">
               <a:ext uri="{FF2B5EF4-FFF2-40B4-BE49-F238E27FC236}">
-                <a16:creationId xmlns:a16="http://schemas.microsoft.com/office/drawing/2014/main" id="{4CE0065D-5EB8-4339-ACFA-AE42596C9359}"/>
+                <a16:creationId xmlns:a16="http://schemas.microsoft.com/office/drawing/2014/main" id="{8DDAFA52-6367-4238-9BB4-768C70AA4EF8}"/>
               </a:ext>
             </a:extLst>
           </p:cNvPr>
@@ -13572,7 +13572,7 @@
           <p:cNvPr id="27" name="Cover headline">
             <a:extLst xmlns:a="http://schemas.openxmlformats.org/drawingml/2006/main">
               <a:ext uri="{FF2B5EF4-FFF2-40B4-BE49-F238E27FC236}">
-                <a16:creationId xmlns:a16="http://schemas.microsoft.com/office/drawing/2014/main" id="{8CBE2181-4D8D-4183-87C0-4C0DC34EEB5C}"/>
+                <a16:creationId xmlns:a16="http://schemas.microsoft.com/office/drawing/2014/main" id="{631D3BB1-B84A-4F1A-91B1-B81AA90FD52A}"/>
               </a:ext>
             </a:extLst>
           </p:cNvPr>
@@ -20531,7 +20531,7 @@
           <p:nvPr/>
         </p:nvPicPr>
         <p:blipFill>
-          <a:blip xmlns:r="http://schemas.openxmlformats.org/officeDocument/2006/relationships" xmlns:a="http://schemas.openxmlformats.org/drawingml/2006/main" r:embed="R21cc5a4f53fd49d5"/>
+          <a:blip xmlns:r="http://schemas.openxmlformats.org/officeDocument/2006/relationships" xmlns:a="http://schemas.openxmlformats.org/drawingml/2006/main" r:embed="R86df5b826a86489e"/>
           <a:stretch xmlns:a="http://schemas.openxmlformats.org/drawingml/2006/main">
             <a:fillRect l="0" t="0" r="0" b="0"/>
           </a:stretch>
@@ -23679,7 +23679,7 @@
           <p:nvPr/>
         </p:nvPicPr>
         <p:blipFill>
-          <a:blip xmlns:r="http://schemas.openxmlformats.org/officeDocument/2006/relationships" xmlns:a="http://schemas.openxmlformats.org/drawingml/2006/main" r:embed="Rc6c9d0f22e544c33"/>
+          <a:blip xmlns:r="http://schemas.openxmlformats.org/officeDocument/2006/relationships" xmlns:a="http://schemas.openxmlformats.org/drawingml/2006/main" r:embed="R244544af19284559"/>
           <a:stretch xmlns:a="http://schemas.openxmlformats.org/drawingml/2006/main">
             <a:fillRect l="0" t="0" r="0" b="0"/>
           </a:stretch>
@@ -23956,7 +23956,7 @@
           <p:nvPr/>
         </p:nvPicPr>
         <p:blipFill>
-          <a:blip xmlns:r="http://schemas.openxmlformats.org/officeDocument/2006/relationships" xmlns:a="http://schemas.openxmlformats.org/drawingml/2006/main" r:embed="R1c2d29df41ef4b2d"/>
+          <a:blip xmlns:r="http://schemas.openxmlformats.org/officeDocument/2006/relationships" xmlns:a="http://schemas.openxmlformats.org/drawingml/2006/main" r:embed="R6703f6839a254431"/>
           <a:stretch xmlns:a="http://schemas.openxmlformats.org/drawingml/2006/main">
             <a:fillRect l="0" t="0" r="0" b="0"/>
           </a:stretch>
@@ -24233,7 +24233,7 @@
           <p:nvPr/>
         </p:nvPicPr>
         <p:blipFill>
-          <a:blip xmlns:r="http://schemas.openxmlformats.org/officeDocument/2006/relationships" xmlns:a="http://schemas.openxmlformats.org/drawingml/2006/main" r:embed="Re447760404cc45fc"/>
+          <a:blip xmlns:r="http://schemas.openxmlformats.org/officeDocument/2006/relationships" xmlns:a="http://schemas.openxmlformats.org/drawingml/2006/main" r:embed="Raeb332e8027e4af5"/>
           <a:stretch xmlns:a="http://schemas.openxmlformats.org/drawingml/2006/main">
             <a:fillRect l="0" t="0" r="0" b="0"/>
           </a:stretch>
@@ -24510,7 +24510,7 @@
           <p:nvPr/>
         </p:nvPicPr>
         <p:blipFill>
-          <a:blip xmlns:r="http://schemas.openxmlformats.org/officeDocument/2006/relationships" xmlns:a="http://schemas.openxmlformats.org/drawingml/2006/main" r:embed="R859ecf513c2e4d7c"/>
+          <a:blip xmlns:r="http://schemas.openxmlformats.org/officeDocument/2006/relationships" xmlns:a="http://schemas.openxmlformats.org/drawingml/2006/main" r:embed="Re27c0de8bb0e49d2"/>
           <a:stretch xmlns:a="http://schemas.openxmlformats.org/drawingml/2006/main">
             <a:fillRect l="0" t="0" r="0" b="0"/>
           </a:stretch>
@@ -25197,7 +25197,7 @@
           <p:nvPr/>
         </p:nvPicPr>
         <p:blipFill>
-          <a:blip xmlns:r="http://schemas.openxmlformats.org/officeDocument/2006/relationships" xmlns:a="http://schemas.openxmlformats.org/drawingml/2006/main" r:embed="Ra008eda65b0c4499"/>
+          <a:blip xmlns:r="http://schemas.openxmlformats.org/officeDocument/2006/relationships" xmlns:a="http://schemas.openxmlformats.org/drawingml/2006/main" r:embed="R0ffcdba06ea54d68"/>
           <a:stretch xmlns:a="http://schemas.openxmlformats.org/drawingml/2006/main">
             <a:fillRect l="0" t="0" r="0" b="0"/>
           </a:stretch>
@@ -25474,7 +25474,7 @@
           <p:nvPr/>
         </p:nvPicPr>
         <p:blipFill>
-          <a:blip xmlns:r="http://schemas.openxmlformats.org/officeDocument/2006/relationships" xmlns:a="http://schemas.openxmlformats.org/drawingml/2006/main" r:embed="R5df2a5c5f23d4b23"/>
+          <a:blip xmlns:r="http://schemas.openxmlformats.org/officeDocument/2006/relationships" xmlns:a="http://schemas.openxmlformats.org/drawingml/2006/main" r:embed="Rc43109d1bf2445e1"/>
           <a:stretch xmlns:a="http://schemas.openxmlformats.org/drawingml/2006/main">
             <a:fillRect l="0" t="0" r="0" b="0"/>
           </a:stretch>
@@ -25751,7 +25751,7 @@
           <p:nvPr/>
         </p:nvPicPr>
         <p:blipFill>
-          <a:blip xmlns:r="http://schemas.openxmlformats.org/officeDocument/2006/relationships" xmlns:a="http://schemas.openxmlformats.org/drawingml/2006/main" r:embed="Raaae5253cea54625"/>
+          <a:blip xmlns:r="http://schemas.openxmlformats.org/officeDocument/2006/relationships" xmlns:a="http://schemas.openxmlformats.org/drawingml/2006/main" r:embed="R2cb1313ce8ac4aad"/>
           <a:stretch xmlns:a="http://schemas.openxmlformats.org/drawingml/2006/main">
             <a:fillRect l="0" t="0" r="0" b="0"/>
           </a:stretch>

</xml_diff>